<commit_message>
Rebuild v3 run artifacts on the legend fix (attempts not logged)
Co-authored-by: Audge <audr3x@users.noreply.github.com>
</commit_message>
<xml_diff>
--- a/evals/runs/claude-opus-5.5/T03-qbr-pptx/deck.pptx
+++ b/evals/runs/claude-opus-5.5/T03-qbr-pptx/deck.pptx
@@ -521,8 +521,8 @@
       </c:valAx>
     </c:plotArea>
     <c:legend>
-      <c:legendPos/>
-      <c:overlay val="1"/>
+      <c:legendPos val="b"/>
+      <c:overlay val="0"/>
       <c:txPr>
         <a:bodyPr/>
         <a:lstStyle/>

</xml_diff>